<commit_message>
docs(slides): add cross-dataset label-handling to all 4 comparison decks
- compTable: new "Cross-dataset labels" row (Stanford per-dataset, retrain
  or hand-map  vs  ECGFounder fixed 150-space, centralized mapping) — now
  in the 1/2/3/6-page decks; tuned row heights so tables stay in-bounds.
- 6-page: added a dedicated "Label handling across databases" slide
  (Stanford no-global-label-space + retrain/hand-map  vs  ECGFounder fixed
  vocabulary + centralized, import-time-enforced mapping) → 7 slides.
- Mirrors docs/STANFORD_VS_ECGFOUNDER.md §3a. QA: python-pptx, 0 out-of-bounds.

Co-Authored-By: Claude Opus 4.8 (1M context) <noreply@anthropic.com>
</commit_message>
<xml_diff>
--- a/docs/Stanford_vs_ECGFounder_1page.pptx
+++ b/docs/Stanford_vs_ECGFounder_1page.pptx
@@ -968,7 +968,7 @@
           </p:nvPr>
         </p:nvGraphicFramePr>
         <p:xfrm>
-          <a:off x="548640" y="1417320"/>
+          <a:off x="548640" y="1371600"/>
           <a:ext cx="11064240" cy="914400"/>
         </p:xfrm>
         <a:graphic>
@@ -980,7 +980,7 @@
                 <a:gridCol w="4204411"/>
                 <a:gridCol w="4204411"/>
               </a:tblGrid>
-              <a:tr h="475488">
+              <a:tr h="384048">
                 <a:tc>
                   <a:txBody>
                     <a:bodyPr/>
@@ -1186,7 +1186,7 @@
                   </a:tcPr>
                 </a:tc>
               </a:tr>
-              <a:tr h="475488">
+              <a:tr h="384048">
                 <a:tc>
                   <a:txBody>
                     <a:bodyPr/>
@@ -1386,7 +1386,7 @@
                   </a:tcPr>
                 </a:tc>
               </a:tr>
-              <a:tr h="475488">
+              <a:tr h="384048">
                 <a:tc>
                   <a:txBody>
                     <a:bodyPr/>
@@ -1586,7 +1586,7 @@
                   </a:tcPr>
                 </a:tc>
               </a:tr>
-              <a:tr h="475488">
+              <a:tr h="384048">
                 <a:tc>
                   <a:txBody>
                     <a:bodyPr/>
@@ -1786,7 +1786,7 @@
                   </a:tcPr>
                 </a:tc>
               </a:tr>
-              <a:tr h="475488">
+              <a:tr h="384048">
                 <a:tc>
                   <a:txBody>
                     <a:bodyPr/>
@@ -1986,7 +1986,7 @@
                   </a:tcPr>
                 </a:tc>
               </a:tr>
-              <a:tr h="475488">
+              <a:tr h="384048">
                 <a:tc>
                   <a:txBody>
                     <a:bodyPr/>
@@ -2186,7 +2186,7 @@
                   </a:tcPr>
                 </a:tc>
               </a:tr>
-              <a:tr h="475488">
+              <a:tr h="384048">
                 <a:tc>
                   <a:txBody>
                     <a:bodyPr/>
@@ -2386,6 +2386,206 @@
                   </a:tcPr>
                 </a:tc>
               </a:tr>
+              <a:tr h="384048">
+                <a:tc>
+                  <a:txBody>
+                    <a:bodyPr/>
+                    <a:lstStyle/>
+                    <a:p>
+                      <a:pPr indent="0" marL="0">
+                        <a:buNone/>
+                      </a:pPr>
+                      <a:r>
+                        <a:rPr lang="en-US" sz="1300" b="1" dirty="0">
+                          <a:solidFill>
+                            <a:srgbClr val="21295C"/>
+                          </a:solidFill>
+                          <a:latin typeface="Calibri" pitchFamily="34" charset="0"/>
+                          <a:ea typeface="Calibri" pitchFamily="34" charset="-122"/>
+                          <a:cs typeface="Calibri" pitchFamily="34" charset="-120"/>
+                        </a:rPr>
+                        <a:t>Cross-dataset labels</a:t>
+                      </a:r>
+                      <a:endParaRPr lang="en-US" sz="1300" dirty="0">
+                        <a:latin typeface="Calibri" charset="0"/>
+                        <a:ea typeface="Calibri" charset="0"/>
+                        <a:cs typeface="Calibri" charset="0"/>
+                      </a:endParaRPr>
+                    </a:p>
+                  </a:txBody>
+                  <a:tcPr marL="63500" marR="63500" marT="63500" marB="63500" anchor="ctr">
+                    <a:lnL w="6350" cap="flat" cmpd="sng" algn="ctr">
+                      <a:solidFill>
+                        <a:srgbClr val="D6DEE6"/>
+                      </a:solidFill>
+                      <a:prstDash val="solid"/>
+                      <a:round/>
+                      <a:headEnd type="none" w="med" len="med"/>
+                      <a:tailEnd type="none" w="med" len="med"/>
+                    </a:lnL>
+                    <a:lnR w="6350" cap="flat" cmpd="sng" algn="ctr">
+                      <a:solidFill>
+                        <a:srgbClr val="D6DEE6"/>
+                      </a:solidFill>
+                      <a:prstDash val="solid"/>
+                      <a:round/>
+                      <a:headEnd type="none" w="med" len="med"/>
+                      <a:tailEnd type="none" w="med" len="med"/>
+                    </a:lnR>
+                    <a:lnT w="6350" cap="flat" cmpd="sng" algn="ctr">
+                      <a:solidFill>
+                        <a:srgbClr val="D6DEE6"/>
+                      </a:solidFill>
+                      <a:prstDash val="solid"/>
+                      <a:round/>
+                      <a:headEnd type="none" w="med" len="med"/>
+                      <a:tailEnd type="none" w="med" len="med"/>
+                    </a:lnT>
+                    <a:lnB w="6350" cap="flat" cmpd="sng" algn="ctr">
+                      <a:solidFill>
+                        <a:srgbClr val="D6DEE6"/>
+                      </a:solidFill>
+                      <a:prstDash val="solid"/>
+                      <a:round/>
+                      <a:headEnd type="none" w="med" len="med"/>
+                      <a:tailEnd type="none" w="med" len="med"/>
+                    </a:lnB>
+                    <a:solidFill>
+                      <a:srgbClr val="F4F7FA"/>
+                    </a:solidFill>
+                  </a:tcPr>
+                </a:tc>
+                <a:tc>
+                  <a:txBody>
+                    <a:bodyPr/>
+                    <a:lstStyle/>
+                    <a:p>
+                      <a:pPr indent="0" marL="0">
+                        <a:buNone/>
+                      </a:pPr>
+                      <a:r>
+                        <a:rPr lang="en-US" sz="1300" b="1" dirty="0">
+                          <a:solidFill>
+                            <a:srgbClr val="1A2233"/>
+                          </a:solidFill>
+                          <a:latin typeface="Calibri" pitchFamily="34" charset="0"/>
+                          <a:ea typeface="Calibri" pitchFamily="34" charset="-122"/>
+                          <a:cs typeface="Calibri" pitchFamily="34" charset="-120"/>
+                        </a:rPr>
+                        <a:t>per-dataset; retrain or hand-map</a:t>
+                      </a:r>
+                      <a:endParaRPr lang="en-US" sz="1300" dirty="0">
+                        <a:latin typeface="Calibri" charset="0"/>
+                        <a:ea typeface="Calibri" charset="0"/>
+                        <a:cs typeface="Calibri" charset="0"/>
+                      </a:endParaRPr>
+                    </a:p>
+                  </a:txBody>
+                  <a:tcPr marL="63500" marR="63500" marT="63500" marB="63500" anchor="ctr">
+                    <a:lnL w="6350" cap="flat" cmpd="sng" algn="ctr">
+                      <a:solidFill>
+                        <a:srgbClr val="D6DEE6"/>
+                      </a:solidFill>
+                      <a:prstDash val="solid"/>
+                      <a:round/>
+                      <a:headEnd type="none" w="med" len="med"/>
+                      <a:tailEnd type="none" w="med" len="med"/>
+                    </a:lnL>
+                    <a:lnR w="6350" cap="flat" cmpd="sng" algn="ctr">
+                      <a:solidFill>
+                        <a:srgbClr val="D6DEE6"/>
+                      </a:solidFill>
+                      <a:prstDash val="solid"/>
+                      <a:round/>
+                      <a:headEnd type="none" w="med" len="med"/>
+                      <a:tailEnd type="none" w="med" len="med"/>
+                    </a:lnR>
+                    <a:lnT w="6350" cap="flat" cmpd="sng" algn="ctr">
+                      <a:solidFill>
+                        <a:srgbClr val="D6DEE6"/>
+                      </a:solidFill>
+                      <a:prstDash val="solid"/>
+                      <a:round/>
+                      <a:headEnd type="none" w="med" len="med"/>
+                      <a:tailEnd type="none" w="med" len="med"/>
+                    </a:lnT>
+                    <a:lnB w="6350" cap="flat" cmpd="sng" algn="ctr">
+                      <a:solidFill>
+                        <a:srgbClr val="D6DEE6"/>
+                      </a:solidFill>
+                      <a:prstDash val="solid"/>
+                      <a:round/>
+                      <a:headEnd type="none" w="med" len="med"/>
+                      <a:tailEnd type="none" w="med" len="med"/>
+                    </a:lnB>
+                  </a:tcPr>
+                </a:tc>
+                <a:tc>
+                  <a:txBody>
+                    <a:bodyPr/>
+                    <a:lstStyle/>
+                    <a:p>
+                      <a:pPr indent="0" marL="0">
+                        <a:buNone/>
+                      </a:pPr>
+                      <a:r>
+                        <a:rPr lang="en-US" sz="1300" b="1" dirty="0">
+                          <a:solidFill>
+                            <a:srgbClr val="1A2233"/>
+                          </a:solidFill>
+                          <a:latin typeface="Calibri" pitchFamily="34" charset="0"/>
+                          <a:ea typeface="Calibri" pitchFamily="34" charset="-122"/>
+                          <a:cs typeface="Calibri" pitchFamily="34" charset="-120"/>
+                        </a:rPr>
+                        <a:t>fixed 150-space; central map</a:t>
+                      </a:r>
+                      <a:endParaRPr lang="en-US" sz="1300" dirty="0">
+                        <a:latin typeface="Calibri" charset="0"/>
+                        <a:ea typeface="Calibri" charset="0"/>
+                        <a:cs typeface="Calibri" charset="0"/>
+                      </a:endParaRPr>
+                    </a:p>
+                  </a:txBody>
+                  <a:tcPr marL="63500" marR="63500" marT="63500" marB="63500" anchor="ctr">
+                    <a:lnL w="6350" cap="flat" cmpd="sng" algn="ctr">
+                      <a:solidFill>
+                        <a:srgbClr val="D6DEE6"/>
+                      </a:solidFill>
+                      <a:prstDash val="solid"/>
+                      <a:round/>
+                      <a:headEnd type="none" w="med" len="med"/>
+                      <a:tailEnd type="none" w="med" len="med"/>
+                    </a:lnL>
+                    <a:lnR w="6350" cap="flat" cmpd="sng" algn="ctr">
+                      <a:solidFill>
+                        <a:srgbClr val="D6DEE6"/>
+                      </a:solidFill>
+                      <a:prstDash val="solid"/>
+                      <a:round/>
+                      <a:headEnd type="none" w="med" len="med"/>
+                      <a:tailEnd type="none" w="med" len="med"/>
+                    </a:lnR>
+                    <a:lnT w="6350" cap="flat" cmpd="sng" algn="ctr">
+                      <a:solidFill>
+                        <a:srgbClr val="D6DEE6"/>
+                      </a:solidFill>
+                      <a:prstDash val="solid"/>
+                      <a:round/>
+                      <a:headEnd type="none" w="med" len="med"/>
+                      <a:tailEnd type="none" w="med" len="med"/>
+                    </a:lnT>
+                    <a:lnB w="6350" cap="flat" cmpd="sng" algn="ctr">
+                      <a:solidFill>
+                        <a:srgbClr val="D6DEE6"/>
+                      </a:solidFill>
+                      <a:prstDash val="solid"/>
+                      <a:round/>
+                      <a:headEnd type="none" w="med" len="med"/>
+                      <a:tailEnd type="none" w="med" len="med"/>
+                    </a:lnB>
+                  </a:tcPr>
+                </a:tc>
+              </a:tr>
             </a:tbl>
           </a:graphicData>
         </a:graphic>
@@ -2398,8 +2598,8 @@
         </p:nvSpPr>
         <p:spPr>
           <a:xfrm>
-            <a:off x="548640" y="4892040"/>
-            <a:ext cx="11064240" cy="365760"/>
+            <a:off x="548640" y="4937760"/>
+            <a:ext cx="11064240" cy="320040"/>
           </a:xfrm>
           <a:prstGeom prst="rect">
             <a:avLst/>
@@ -2415,7 +2615,7 @@
               <a:buNone/>
             </a:pPr>
             <a:r>
-              <a:rPr lang="en-US" sz="1300" b="1" dirty="0">
+              <a:rPr lang="en-US" sz="1250" b="1" dirty="0">
                 <a:solidFill>
                   <a:srgbClr val="21295C"/>
                 </a:solidFill>
@@ -2429,7 +2629,7 @@
               <a:buNone/>
             </a:pPr>
             <a:r>
-              <a:rPr lang="en-US" sz="1300" dirty="0">
+              <a:rPr lang="en-US" sz="1250" dirty="0">
                 <a:solidFill>
                   <a:srgbClr val="1A2233"/>
                 </a:solidFill>
@@ -2439,7 +2639,7 @@
               </a:rPr>
               <a:t>Stanford ~1.00 acc (trained on it, in-distribution)   vs   ECGFounder AFib ROC 0.95 (zero-shot transfer).</a:t>
             </a:r>
-            <a:endParaRPr lang="en-US" sz="1300" dirty="0"/>
+            <a:endParaRPr lang="en-US" sz="1250" dirty="0"/>
           </a:p>
         </p:txBody>
       </p:sp>
@@ -2452,7 +2652,7 @@
         <p:spPr>
           <a:xfrm>
             <a:off x="548640" y="5349240"/>
-            <a:ext cx="11064240" cy="1371600"/>
+            <a:ext cx="11064240" cy="1325880"/>
           </a:xfrm>
           <a:prstGeom prst="rect">
             <a:avLst/>
@@ -2477,7 +2677,7 @@
         <p:spPr>
           <a:xfrm>
             <a:off x="548640" y="5349240"/>
-            <a:ext cx="118872" cy="1371600"/>
+            <a:ext cx="118872" cy="1325880"/>
           </a:xfrm>
           <a:prstGeom prst="rect">
             <a:avLst/>
@@ -2536,7 +2736,7 @@
         <p:spPr>
           <a:xfrm>
             <a:off x="868680" y="5897880"/>
-            <a:ext cx="10515600" cy="731520"/>
+            <a:ext cx="10515600" cy="685800"/>
           </a:xfrm>
           <a:prstGeom prst="rect">
             <a:avLst/>

</xml_diff>